<commit_message>
Chapter 6 - Task - PPT correction
</commit_message>
<xml_diff>
--- a/Python Programming/Chapter-5/Sleep Health and Lifestyle.pptx
+++ b/Python Programming/Chapter-5/Sleep Health and Lifestyle.pptx
@@ -116,6 +116,11 @@
       </a:defRPr>
     </a:lvl9pPr>
   </p:defaultTextStyle>
+  <p:extLst>
+    <p:ext uri="{EFAFB233-063F-42B5-8137-9DF3F51BA10A}">
+      <p15:sldGuideLst xmlns:p15="http://schemas.microsoft.com/office/powerpoint/2012/main"/>
+    </p:ext>
+  </p:extLst>
 </p:presentation>
 </file>
 
@@ -6097,31 +6102,37 @@
         </p:nvSpPr>
         <p:spPr>
           <a:xfrm>
-            <a:off x="3204742" y="4657156"/>
+            <a:off x="3204742" y="4728875"/>
             <a:ext cx="5779340" cy="1779495"/>
           </a:xfrm>
         </p:spPr>
         <p:txBody>
           <a:bodyPr>
-            <a:normAutofit fontScale="92500"/>
+            <a:normAutofit fontScale="85000" lnSpcReduction="10000"/>
           </a:bodyPr>
           <a:lstStyle/>
           <a:p>
             <a:r>
-              <a:rPr lang="en-US" dirty="0"/>
-              <a:t>Doctors, Nurses, Engineers and Teachers show differing patterns</a:t>
-            </a:r>
-          </a:p>
-          <a:p>
-            <a:r>
-              <a:rPr lang="en-US" dirty="0"/>
-              <a:t>Occupation influences stress and sleep duration</a:t>
-            </a:r>
-          </a:p>
-          <a:p>
-            <a:r>
-              <a:rPr lang="en-US" dirty="0"/>
-              <a:t>Workload likely contributes to sleep outcomes</a:t>
+              <a:rPr lang="en-US" dirty="0">
+                <a:effectLst/>
+              </a:rPr>
+              <a:t>The scientists, sales people has the less sleep duration due to the higher stress in the work place.</a:t>
+            </a:r>
+          </a:p>
+          <a:p>
+            <a:r>
+              <a:rPr lang="en-US" dirty="0">
+                <a:effectLst/>
+              </a:rPr>
+              <a:t>Though there is high stress in the work place, the doctors are being health conscious.</a:t>
+            </a:r>
+          </a:p>
+          <a:p>
+            <a:r>
+              <a:rPr lang="en-US" dirty="0">
+                <a:effectLst/>
+              </a:rPr>
+              <a:t>Also, the fun fact is that, the engineers are sleeping longer time despite low stress in the job.</a:t>
             </a:r>
           </a:p>
         </p:txBody>

</xml_diff>